<commit_message>
Case 3b: profit sharing only from year 15 (when benefits begin)
return_book.py: add profit_share_start_year (=15). Years 1-14 the whole
investment return compounds in the book un-shared; from year 15 the 90/10 split
applies to payout-phase returns. horizon_years 10 -> 20 to show the payout
phase.

- Deployed return book (return_book_mode="projected") is now the year-10
  pre-sharing MV = EUR 8.39bn (was 5.26bn); projected-mode assets 10.26 ->
  13.39bn, HS Asset VaR ~3.22bn / Surplus VaR ~1.42bn.
- Payout phase (yr 15-20, deterministic projection): ~EUR 7.8bn cumulative to
  policyholders, ~EUR 0.9bn retained, book ~EUR 13.6bn at year 20.
- Headline VaR unchanged - still on the conservative flat EUR 5.0bn return book
  (return_book_mode="sum").

Updated deck slide 37 + profit_share chart (yr-15 marker), README_case3_model.md.

Co-Authored-By: Claude Sonnet 5 <noreply@anthropic.com>
</commit_message>
<xml_diff>
--- a/Case 3/presentation/All-Kanns_Asset_Management.pptx
+++ b/Case 3/presentation/All-Kanns_Asset_Management.pptx
@@ -17341,7 +17341,7 @@
                 </a:solidFill>
                 <a:latin typeface="Calibri"/>
               </a:rPr>
-              <a:t>a cash-flow- and key-rate-matched bond book clears the €11.3bn guaranteed floor; the surplus funds an aggressive, diversified return portfolio with a 90/10 policyholder profit share. A par receiver-IRS overlay (no cash outlay) closes the residual duration gap.</a:t>
+              <a:t>a cash-flow- and key-rate-matched bond book clears the €11.3bn guaranteed floor; the surplus funds an aggressive, diversified return portfolio, with a 90/10 policyholder profit share from year 15. A par receiver-IRS overlay (no cash outlay) closes the residual duration gap.</a:t>
             </a:r>
           </a:p>
         </p:txBody>
@@ -40264,7 +40264,7 @@
                 </a:solidFill>
                 <a:latin typeface="Calibri Light"/>
               </a:rPr>
-              <a:t>Sharing the Upside – 90 / 10 on the Return Portfolio</a:t>
+              <a:t>Sharing the Upside – 90 / 10 From Year 15</a:t>
             </a:r>
           </a:p>
         </p:txBody>
@@ -40306,7 +40306,7 @@
                 </a:solidFill>
                 <a:latin typeface="Calibri"/>
               </a:rPr>
-              <a:t>A requirement: 90% of the return book's yearly profit goes to policyholders</a:t>
+              <a:t>The whole return compounds until benefits begin; then 90% of profit goes to policyholders</a:t>
             </a:r>
           </a:p>
         </p:txBody>
@@ -40838,7 +40838,7 @@
               </a:spcAft>
             </a:pPr>
             <a:r>
-              <a:rPr sz="930" b="0" i="0">
+              <a:rPr sz="919" b="0" i="0">
                 <a:solidFill>
                   <a:srgbClr val="333333"/>
                 </a:solidFill>
@@ -40847,22 +40847,22 @@
               <a:t>•  </a:t>
             </a:r>
             <a:r>
-              <a:rPr sz="930" b="1" i="0">
+              <a:rPr sz="919" b="1" i="0">
                 <a:solidFill>
                   <a:srgbClr val="1F4E5F"/>
                 </a:solidFill>
                 <a:latin typeface="Calibri"/>
               </a:rPr>
-              <a:t>90% to policyholders.  </a:t>
-            </a:r>
-            <a:r>
-              <a:rPr sz="930" b="0" i="0">
+              <a:t>Years 1–14: no sharing.  </a:t>
+            </a:r>
+            <a:r>
+              <a:rPr sz="919" b="0" i="0">
                 <a:solidFill>
                   <a:srgbClr val="333333"/>
                 </a:solidFill>
                 <a:latin typeface="Calibri"/>
               </a:rPr>
-              <a:t>each year's investment profit on the RSP is 90% distributed, funded by selling an equal EUR amount from every sleeve.</a:t>
+              <a:t>the whole investment return compounds in the book – contributions €5.0bn → return-book MV ≈ €8.4bn by year 10.</a:t>
             </a:r>
           </a:p>
           <a:p>
@@ -40875,7 +40875,7 @@
               </a:spcAft>
             </a:pPr>
             <a:r>
-              <a:rPr sz="930" b="0" i="0">
+              <a:rPr sz="919" b="0" i="0">
                 <a:solidFill>
                   <a:srgbClr val="333333"/>
                 </a:solidFill>
@@ -40884,22 +40884,22 @@
               <a:t>•  </a:t>
             </a:r>
             <a:r>
-              <a:rPr sz="930" b="1" i="0">
+              <a:rPr sz="919" b="1" i="0">
                 <a:solidFill>
                   <a:srgbClr val="1F4E5F"/>
                 </a:solidFill>
                 <a:latin typeface="Calibri"/>
               </a:rPr>
-              <a:t>10% retained, reinvested.  </a:t>
-            </a:r>
-            <a:r>
-              <a:rPr sz="930" b="0" i="0">
+              <a:t>Year 15+: 90 / 10.  </a:t>
+            </a:r>
+            <a:r>
+              <a:rPr sz="919" b="0" i="0">
                 <a:solidFill>
                   <a:srgbClr val="333333"/>
                 </a:solidFill>
                 <a:latin typeface="Calibri"/>
               </a:rPr>
-              <a:t>stays in the book and compounds; losses carry forward and net against future profit first.</a:t>
+              <a:t>90% of each year's investment profit paid to policyholders (equal EUR sold from every sleeve), 10% retained and reinvested; losses carry forward first.</a:t>
             </a:r>
           </a:p>
           <a:p>
@@ -40912,7 +40912,7 @@
               </a:spcAft>
             </a:pPr>
             <a:r>
-              <a:rPr sz="930" b="0" i="0">
+              <a:rPr sz="919" b="0" i="0">
                 <a:solidFill>
                   <a:srgbClr val="333333"/>
                 </a:solidFill>
@@ -40921,22 +40921,22 @@
               <a:t>•  </a:t>
             </a:r>
             <a:r>
-              <a:rPr sz="930" b="1" i="0">
+              <a:rPr sz="919" b="1" i="0">
                 <a:solidFill>
                   <a:srgbClr val="1F4E5F"/>
                 </a:solidFill>
                 <a:latin typeface="Calibri"/>
               </a:rPr>
-              <a:t>Over the 10-year accumulation.  </a:t>
-            </a:r>
-            <a:r>
-              <a:rPr sz="930" b="0" i="0">
+              <a:t>Payout phase (yr 15–20).  </a:t>
+            </a:r>
+            <a:r>
+              <a:rPr sz="919" b="0" i="0">
                 <a:solidFill>
                   <a:srgbClr val="333333"/>
                 </a:solidFill>
                 <a:latin typeface="Calibri"/>
               </a:rPr>
-              <a:t>contributions €5.00bn → return-book MV €5.26bn; €2.31bn shared to policyholders; €0.26bn retained.</a:t>
+              <a:t>≈ €7.8bn cumulative to policyholders, ≈ €0.9bn retained; book ≈ €13.6bn at year 20 (deterministic-return projection).</a:t>
             </a:r>
           </a:p>
           <a:p>
@@ -40949,7 +40949,7 @@
               </a:spcAft>
             </a:pPr>
             <a:r>
-              <a:rPr sz="930" b="0" i="0">
+              <a:rPr sz="919" b="0" i="0">
                 <a:solidFill>
                   <a:srgbClr val="333333"/>
                 </a:solidFill>
@@ -40958,7 +40958,7 @@
               <a:t>•  </a:t>
             </a:r>
             <a:r>
-              <a:rPr sz="930" b="1" i="0">
+              <a:rPr sz="919" b="1" i="0">
                 <a:solidFill>
                   <a:srgbClr val="1F4E5F"/>
                 </a:solidFill>
@@ -40967,7 +40967,7 @@
               <a:t>Guarantee untouched.  </a:t>
             </a:r>
             <a:r>
-              <a:rPr sz="930" b="0" i="0">
+              <a:rPr sz="919" b="0" i="0">
                 <a:solidFill>
                   <a:srgbClr val="333333"/>
                 </a:solidFill>
@@ -41015,7 +41015,7 @@
                 </a:solidFill>
                 <a:latin typeface="Calibri"/>
               </a:rPr>
-              <a:t>Source: return_book.py / results_var/RETURN_BOOK_REPORT.md.  Naive fully-reinvested book (no share) would be €8.39bn.</a:t>
+              <a:t>Source: return_book.py (profit_share_start_year = 15).  Headline VaR uses the conservative flat €5.0bn return book; the projected €8.4bn book is the 'full_projected' sensitivity (assets €13.4bn, Surplus VaR €1.42bn).</a:t>
             </a:r>
           </a:p>
         </p:txBody>

</xml_diff>